<commit_message>
fix(slides): correct all 19 decks against current lab state + fix pptx generator bugs
Every week's deck had drifted from what its lab actually teaches/grades now -
wrong payloads, stale exam scope (two decks misstated graded content on
exam day), broken copy-paste commands, and outdated game/deliverable
structure. Each fix was checked against the live lab code or an adversarial
re-verification pass, not just re-read.

Also fixes two bugs in the pptx generator: a box-height bug that silently
dropped list items once a slide ran out of its fixed vertical budget (no
error, no visual sign - the content was just gone), and a markdown-strip
bug that ate literal asterisks out of inline code spans, e.g. turning
`Resource:"*"` into `Resource:""` on the one slide where the wildcard was
the entire point.

Co-Authored-By: Claude Sonnet 5 <noreply@anthropic.com>
</commit_message>
<xml_diff>
--- a/slides/pptx/week01.pptx
+++ b/slides/pptx/week01.pptx
@@ -22,9 +22,10 @@
     <p:sldId id="270" r:id="rId16"/>
     <p:sldId id="271" r:id="rId17"/>
     <p:sldId id="272" r:id="rId18"/>
+    <p:sldId id="273" r:id="rId19"/>
   </p:sldIdLst>
   <p:notesMasterIdLst>
-    <p:notesMasterId r:id="rId19"/>
+    <p:notesMasterId r:id="rId20"/>
   </p:notesMasterIdLst>
   <p:sldSz cx="9144000" cy="5143500"/>
   <p:notesSz cx="5143500" cy="9144000"/>
@@ -606,7 +607,7 @@
           <a:p>
             <a:r>
               <a:rPr lang="en-US" dirty="0"/>
-              <a:t>Orient them to the references we'll cite weekly. OWASP = what to prevent; CWE = the precise weakness id (e.g., CWE-22 path traversal); ATT&amp;CK = how real adversaries operate. They'll map every finding to a CWE/OWASP id all term. ~3 min.</a:t>
+              <a:t>Orient them to the references we'll cite weekly. OWASP = what to prevent; CWE = the precise weakness id; ATT&amp;CK = how real adversaries operate. Name CWE-501 explicitly here — the worksheet's Reflection Q1 asks them to map their /upload finding to a CWE, and this is the answer the course has already committed to (fixed 2026-07-25, after CWE-1059 turned out to be MITRE-prohibited for vulnerability mapping). They'll map every finding to a CWE/OWASP id all term. ~3 min.</a:t>
             </a:r>
             <a:endParaRPr lang="en-US" dirty="0"/>
           </a:p>
@@ -694,7 +695,7 @@
           <a:p>
             <a:r>
               <a:rPr lang="en-US" dirty="0"/>
-              <a:t>Tie the mindset to the current policy moment (CISA, memory-safety roadmaps). Key idea: threat modeling catches design flaws *before* code exists — cheapest place to fix. Contrast cost of fixing at design vs in production (orders of magnitude). ~4 min.</a:t>
+              <a:t>Tie the mindset to the current policy moment (CISA, memory-safety roadmaps). Key idea: threat modeling catches design flaws *before* code exists — cheapest place to fix. This slide's own thesis is Task 8's actual grading question — make the connection explicit, don't leave it implicit. Contrast cost of fixing at design vs in production (orders of magnitude). ~4 min.</a:t>
             </a:r>
             <a:endParaRPr lang="en-US" dirty="0"/>
           </a:p>
@@ -958,7 +959,7 @@
           <a:p>
             <a:r>
               <a:rPr lang="en-US" dirty="0"/>
-              <a:t>The main lab. They repeat today's /upload worked example across the whole sample app. Remind: rank by likelihood × impact (not everything is critical), and propose a concrete mitigation each. Point them to THREAT-MODEL-TEMPLATE.md. Also: kick off the term project by threat-modeling NoteVault (see worksheet).</a:t>
+              <a:t>This grew from a 4-step propose-only exercise into an 8-part build-and-prove lab (task numbering in the worksheet is 0-8, with a 3b for the systems-level pass) — don't teach the old 4-step version. Two things are new and graded, cite them explicitly: the systems-level pass (step 4, research-grounded — STRIDE-only modeling makes people miss system-level threats) and the implemented-and-evidenced defense (step 8 — this is where "Secure by Design" 4 slides ago stops being theory). Point them to THREAT-MODEL-TEMPLATE.md. Step 6 kicks off the term project.</a:t>
             </a:r>
             <a:endParaRPr lang="en-US" dirty="0"/>
           </a:p>
@@ -1046,7 +1047,7 @@
           <a:p>
             <a:r>
               <a:rPr lang="en-US" dirty="0"/>
-              <a:t>Address AI head-on, week 1. Frame it as a professional skill: future engineers use AI but must verify it. The Audit-the-AI task turns its weakness into the lesson. Be explicit about the integrity controls so expectations are set early. ~4 min.</a:t>
+              <a:t>This grew from a 4-step propose-only exercise into an 8-part build-and-prove lab (task numbering in the worksheet is 0-8, with a 3b for the systems-level pass) — don't teach the old 4-step version. Two things are new and graded, cite them explicitly: the systems-level pass (step 4, research-grounded — STRIDE-only modeling makes people miss system-level threats) and the implemented-and-evidenced defense (step 8 — this is where "Secure by Design" 4 slides ago stops being theory). Point them to THREAT-MODEL-TEMPLATE.md. Step 6 kicks off the term project.</a:t>
             </a:r>
             <a:endParaRPr lang="en-US" dirty="0"/>
           </a:p>
@@ -1134,7 +1135,7 @@
           <a:p>
             <a:r>
               <a:rPr lang="en-US" dirty="0"/>
-              <a:t>Recap in 3 lines. Cold-call 2 students: "give me one STRIDE threat for a login page." Confirm they can do the lab. ~2 min.</a:t>
+              <a:t>Address AI head-on, week 1. Frame it as a professional skill: future engineers use AI but must verify it. The Audit-the-AI task turns its weakness into the lesson. Be explicit about the integrity controls so expectations are set early. ~4 min.</a:t>
             </a:r>
             <a:endParaRPr lang="en-US" dirty="0"/>
           </a:p>
@@ -1222,7 +1223,7 @@
           <a:p>
             <a:r>
               <a:rPr lang="en-US" dirty="0"/>
-              <a:t>Cliffhanger: "Next week we automate finding these bugs — and race to triage them. Get your VM working before then." Take questions; remind about the ethics acknowledgment + Lab 0.</a:t>
+              <a:t>Recap in 3 lines. Cold-call 2 students: "give me one STRIDE threat for a login page." Confirm they can do the lab. ~2 min.</a:t>
             </a:r>
             <a:endParaRPr lang="en-US" dirty="0"/>
           </a:p>
@@ -1246,6 +1247,94 @@
             <a:fld id="{F7021451-1387-4CA6-816F-3879F97B5CBC}" type="slidenum">
               <a:rPr lang="en-US"/>
               <a:t>17</a:t>
+            </a:fld>
+            <a:endParaRPr lang="en-US"/>
+          </a:p>
+        </p:txBody>
+      </p:sp>
+    </p:spTree>
+    <p:extLst>
+      <p:ext uri="{BB962C8B-B14F-4D97-AF65-F5344CB8AC3E}">
+        <p14:creationId xmlns:p14="http://schemas.microsoft.com/office/powerpoint/2010/main" val="1024086991"/>
+      </p:ext>
+    </p:extLst>
+  </p:cSld>
+  <p:clrMapOvr>
+    <a:masterClrMapping/>
+  </p:clrMapOvr>
+</p:notes>
+</file>
+
+<file path=ppt/notesSlides/notesSlide18.xml><?xml version="1.0" encoding="utf-8"?>
+<p:notes xmlns:a="http://schemas.openxmlformats.org/drawingml/2006/main" xmlns:r="http://schemas.openxmlformats.org/officeDocument/2006/relationships" xmlns:p="http://schemas.openxmlformats.org/presentationml/2006/main">
+  <p:cSld>
+    <p:spTree>
+      <p:nvGrpSpPr>
+        <p:cNvPr id="1" name=""/>
+        <p:cNvGrpSpPr/>
+        <p:nvPr/>
+      </p:nvGrpSpPr>
+      <p:grpSpPr>
+        <a:xfrm>
+          <a:off x="0" y="0"/>
+          <a:ext cx="0" cy="0"/>
+          <a:chOff x="0" y="0"/>
+          <a:chExt cx="0" cy="0"/>
+        </a:xfrm>
+      </p:grpSpPr>
+      <p:sp>
+        <p:nvSpPr>
+          <p:cNvPr id="2" name="Slide Image Placeholder 1"/>
+          <p:cNvSpPr>
+            <a:spLocks noGrp="1" noRot="1" noChangeAspect="1"/>
+          </p:cNvSpPr>
+          <p:nvPr>
+            <p:ph type="sldImg"/>
+          </p:nvPr>
+        </p:nvSpPr>
+        <p:spPr/>
+      </p:sp>
+      <p:sp>
+        <p:nvSpPr>
+          <p:cNvPr id="3" name="Notes Placeholder 2"/>
+          <p:cNvSpPr>
+            <a:spLocks noGrp="1"/>
+          </p:cNvSpPr>
+          <p:nvPr>
+            <p:ph type="body" idx="1"/>
+          </p:nvPr>
+        </p:nvSpPr>
+        <p:spPr/>
+        <p:txBody>
+          <a:bodyPr/>
+          <a:lstStyle/>
+          <a:p>
+            <a:r>
+              <a:rPr lang="en-US" dirty="0"/>
+              <a:t>Cliffhanger: "Next week we automate finding these bugs — and race to triage them. Get your VM working before then." Take questions; remind about the ethics acknowledgment + Lab 0.</a:t>
+            </a:r>
+            <a:endParaRPr lang="en-US" dirty="0"/>
+          </a:p>
+        </p:txBody>
+      </p:sp>
+      <p:sp>
+        <p:nvSpPr>
+          <p:cNvPr id="4" name="Slide Number Placeholder 3"/>
+          <p:cNvSpPr>
+            <a:spLocks noGrp="1"/>
+          </p:cNvSpPr>
+          <p:nvPr>
+            <p:ph type="sldNum" sz="quarter" idx="10"/>
+          </p:nvPr>
+        </p:nvSpPr>
+        <p:spPr/>
+        <p:txBody>
+          <a:bodyPr/>
+          <a:lstStyle/>
+          <a:p>
+            <a:fld id="{F7021451-1387-4CA6-816F-3879F97B5CBC}" type="slidenum">
+              <a:rPr lang="en-US"/>
+              <a:t>18</a:t>
             </a:fld>
             <a:endParaRPr lang="en-US"/>
           </a:p>
@@ -1310,7 +1399,7 @@
           <a:p>
             <a:r>
               <a:rPr lang="en-US" dirty="0"/>
-              <a:t>Roadmap slide — 1 min. Tell them the lecture is ~2 h, then a 3 h lab where they threat-model a real app and play the card game. Flag the deliverable early: a 2–3 page threat model. Ask: "Who has heard the word 'threat model' before?" gauge the room.</a:t>
+              <a:t>Roadmap slide — 1 min. Tell them the lecture is ~2 h, then a 3 h lab where they threat-model a real app, play the card game, AND implement one real fix (this grew from a propose-only exercise to a build-and-prove one — see Lab 1 slide). Ask: "Who has heard the word 'threat model' before?" gauge the room.</a:t>
             </a:r>
             <a:endParaRPr lang="en-US" dirty="0"/>
           </a:p>
@@ -1574,7 +1663,7 @@
           <a:p>
             <a:r>
               <a:rPr lang="en-US" dirty="0"/>
-              <a:t>The asymmetry is the whole reason security is hard. Contrast a "use case" (user logs in) with a "misuse case" (attacker logs in as someone else). Exercise: pick the classroom projector login and ask "how would you abuse this?" Get 3 answers. ~5 min.</a:t>
+              <a:t>The asymmetry is the whole reason security is hard. Contrast a "use case" (user logs in) with an "abuse case" (attacker logs in as someone else) — say "abuse case," not "misuse case," to match the worksheet's term (Task 4: 2 personas × 2 abuse cases, graded). Exercise: pick the classroom projector login and ask "how would you abuse this?" Get 3 answers. ~5 min.</a:t>
             </a:r>
             <a:endParaRPr lang="en-US" dirty="0"/>
           </a:p>
@@ -1750,7 +1839,7 @@
           <a:p>
             <a:r>
               <a:rPr lang="en-US" dirty="0"/>
-              <a:t>This is the "make it concrete" moment — walk the data flow on the board. Ask: "what does the app trust here?" (it trusts the filename). Show how a crafted filename escapes the folder. We'll STRIDE this exact element next slide. This worked example is what makes the abstract method click. ~7 min.</a:t>
+              <a:t>This is the "make it concrete" moment — walk the data flow on the board. Ask: "what does the app trust here?" (it trusts the filename, unsanitized, on save). Verified live: /upload writes outside uploads/ with no auth; /files/&lt;name&gt; refuses every traversal encoding tried. Get the direction right — it's a WRITE bug, not a read bug — the rest of today's STRIDE pass depends on this. ~7 min.</a:t>
             </a:r>
             <a:endParaRPr lang="en-US" dirty="0"/>
           </a:p>
@@ -1926,7 +2015,7 @@
           <a:p>
             <a:r>
               <a:rPr lang="en-US" dirty="0"/>
-              <a:t>Pay-off slide: the full STRIDE pass on one element. Let the class call out threats before revealing each line. This models exactly what they'll do in the lab. End with: "6 threats from ONE endpoint — now imagine the whole app." ~6 min.</a:t>
+              <a:t>Pay-off slide: the full STRIDE pass on one element. Let the class call out threats before revealing each line. Verified by running the real sample-app: the traversal bug is a WRITE primitive (Tampering), and the naive "I = read outside the folder" claim does NOT reproduce against /files/&lt;name&gt; — Werkzeug's safe_join blocks it. Don't let this STRIDE pass repeat that error. End with: "5-6 threats from ONE endpoint — now imagine the whole app." ~6 min.</a:t>
             </a:r>
             <a:endParaRPr lang="en-US" dirty="0"/>
           </a:p>
@@ -2574,11 +2663,11 @@
         <p:spPr>
           <a:xfrm>
             <a:off x="457200" y="1325880"/>
-            <a:ext cx="8229600" cy="1517904"/>
+            <a:ext cx="8229600" cy="1719072"/>
           </a:xfrm>
           <a:prstGeom prst="roundRect">
             <a:avLst>
-              <a:gd name="adj" fmla="val 4819"/>
+              <a:gd name="adj" fmla="val 4255"/>
             </a:avLst>
           </a:prstGeom>
           <a:solidFill>
@@ -2603,7 +2692,7 @@
         <p:spPr>
           <a:xfrm>
             <a:off x="731520" y="1435608"/>
-            <a:ext cx="7680960" cy="1298448"/>
+            <a:ext cx="7680960" cy="1499616"/>
           </a:xfrm>
           <a:prstGeom prst="rect">
             <a:avLst/>
@@ -2612,7 +2701,9 @@
           <a:ln/>
         </p:spPr>
         <p:txBody>
-          <a:bodyPr wrap="square" lIns="0" tIns="0" rIns="0" bIns="0" rtlCol="0" anchor="t"/>
+          <a:bodyPr wrap="square" lIns="0" tIns="0" rIns="0" bIns="0" rtlCol="0" anchor="t">
+            <a:normAutofit/>
+          </a:bodyPr>
           <a:lstStyle/>
           <a:p>
             <a:pPr marL="342900" indent="-342900">
@@ -2673,7 +2764,7 @@
                 <a:ea typeface="Calibri" pitchFamily="34" charset="-122"/>
                 <a:cs typeface="Calibri" pitchFamily="34" charset="-120"/>
               </a:rPr>
-              <a:t>MITRE CWE — catalogue of weaknesses</a:t>
+              <a:t>MITRE CWE — catalogue of weaknesses (this week's finding maps to CWE-501, Trust Boundary Violation)</a:t>
             </a:r>
             <a:endParaRPr lang="en-US" sz="1400" dirty="0"/>
           </a:p>
@@ -2894,11 +2985,11 @@
         <p:spPr>
           <a:xfrm>
             <a:off x="457200" y="1325880"/>
-            <a:ext cx="8229600" cy="1517904"/>
+            <a:ext cx="8229600" cy="2029968"/>
           </a:xfrm>
           <a:prstGeom prst="roundRect">
             <a:avLst>
-              <a:gd name="adj" fmla="val 4819"/>
+              <a:gd name="adj" fmla="val 3604"/>
             </a:avLst>
           </a:prstGeom>
           <a:solidFill>
@@ -2923,7 +3014,7 @@
         <p:spPr>
           <a:xfrm>
             <a:off x="731520" y="1435608"/>
-            <a:ext cx="7680960" cy="1298448"/>
+            <a:ext cx="7680960" cy="1810512"/>
           </a:xfrm>
           <a:prstGeom prst="rect">
             <a:avLst/>
@@ -2932,7 +3023,9 @@
           <a:ln/>
         </p:spPr>
         <p:txBody>
-          <a:bodyPr wrap="square" lIns="0" tIns="0" rIns="0" bIns="0" rtlCol="0" anchor="t"/>
+          <a:bodyPr wrap="square" lIns="0" tIns="0" rIns="0" bIns="0" rtlCol="0" anchor="t">
+            <a:normAutofit/>
+          </a:bodyPr>
           <a:lstStyle/>
           <a:p>
             <a:pPr marL="342900" indent="-342900">
@@ -3015,6 +3108,27 @@
                 <a:cs typeface="Calibri" pitchFamily="34" charset="-120"/>
               </a:rPr>
               <a:t>Some bugs are design flaws, not coding slips → A06: Insecure Design</a:t>
+            </a:r>
+            <a:endParaRPr lang="en-US" sz="1400" dirty="0"/>
+          </a:p>
+          <a:p>
+            <a:pPr marL="342900" indent="-342900">
+              <a:spcAft>
+                <a:spcPts val="600"/>
+              </a:spcAft>
+              <a:buSzPct val="100000"/>
+              <a:buChar char="•"/>
+            </a:pPr>
+            <a:r>
+              <a:rPr lang="en-US" sz="1400" dirty="0">
+                <a:solidFill>
+                  <a:srgbClr val="1F2937"/>
+                </a:solidFill>
+                <a:latin typeface="Calibri" pitchFamily="34" charset="0"/>
+                <a:ea typeface="Calibri" pitchFamily="34" charset="-122"/>
+                <a:cs typeface="Calibri" pitchFamily="34" charset="-120"/>
+              </a:rPr>
+              <a:t>Today's lab makes you do this: after you fix /upload, you'll argue whether your fix closes the class of bug or just this one instance</a:t>
             </a:r>
             <a:endParaRPr lang="en-US" sz="1400" dirty="0"/>
           </a:p>
@@ -3252,7 +3366,9 @@
           <a:ln/>
         </p:spPr>
         <p:txBody>
-          <a:bodyPr wrap="square" lIns="0" tIns="0" rIns="0" bIns="0" rtlCol="0" anchor="t"/>
+          <a:bodyPr wrap="square" lIns="0" tIns="0" rIns="0" bIns="0" rtlCol="0" anchor="t">
+            <a:normAutofit/>
+          </a:bodyPr>
           <a:lstStyle/>
           <a:p>
             <a:pPr marL="342900" indent="-342900">
@@ -3593,7 +3709,7 @@
         <p:spPr>
           <a:xfrm>
             <a:off x="1051560" y="1325880"/>
-            <a:ext cx="7589520" cy="384048"/>
+            <a:ext cx="7589520" cy="402336"/>
           </a:xfrm>
           <a:prstGeom prst="rect">
             <a:avLst/>
@@ -3602,7 +3718,9 @@
           <a:ln/>
         </p:spPr>
         <p:txBody>
-          <a:bodyPr wrap="square" lIns="0" tIns="0" rIns="0" bIns="0" rtlCol="0" anchor="ctr"/>
+          <a:bodyPr wrap="square" lIns="0" tIns="0" rIns="0" bIns="0" rtlCol="0" anchor="ctr">
+            <a:normAutofit/>
+          </a:bodyPr>
           <a:lstStyle/>
           <a:p>
             <a:pPr indent="0" marL="0">
@@ -3631,7 +3749,7 @@
         </p:nvSpPr>
         <p:spPr>
           <a:xfrm>
-            <a:off x="502920" y="1783080"/>
+            <a:off x="502920" y="1801368"/>
             <a:ext cx="384048" cy="384048"/>
           </a:xfrm>
           <a:prstGeom prst="ellipse">
@@ -3651,7 +3769,7 @@
         </p:nvSpPr>
         <p:spPr>
           <a:xfrm>
-            <a:off x="502920" y="1783080"/>
+            <a:off x="502920" y="1801368"/>
             <a:ext cx="384048" cy="384048"/>
           </a:xfrm>
           <a:prstGeom prst="rect">
@@ -3690,8 +3808,8 @@
         </p:nvSpPr>
         <p:spPr>
           <a:xfrm>
-            <a:off x="1051560" y="1783080"/>
-            <a:ext cx="7589520" cy="384048"/>
+            <a:off x="1051560" y="1801368"/>
+            <a:ext cx="7589520" cy="402336"/>
           </a:xfrm>
           <a:prstGeom prst="rect">
             <a:avLst/>
@@ -3700,7 +3818,9 @@
           <a:ln/>
         </p:spPr>
         <p:txBody>
-          <a:bodyPr wrap="square" lIns="0" tIns="0" rIns="0" bIns="0" rtlCol="0" anchor="ctr"/>
+          <a:bodyPr wrap="square" lIns="0" tIns="0" rIns="0" bIns="0" rtlCol="0" anchor="ctr">
+            <a:normAutofit/>
+          </a:bodyPr>
           <a:lstStyle/>
           <a:p>
             <a:pPr indent="0" marL="0">
@@ -3729,7 +3849,7 @@
         </p:nvSpPr>
         <p:spPr>
           <a:xfrm>
-            <a:off x="502920" y="2240280"/>
+            <a:off x="502920" y="2276856"/>
             <a:ext cx="384048" cy="384048"/>
           </a:xfrm>
           <a:prstGeom prst="ellipse">
@@ -3749,7 +3869,7 @@
         </p:nvSpPr>
         <p:spPr>
           <a:xfrm>
-            <a:off x="502920" y="2240280"/>
+            <a:off x="502920" y="2276856"/>
             <a:ext cx="384048" cy="384048"/>
           </a:xfrm>
           <a:prstGeom prst="rect">
@@ -3788,8 +3908,8 @@
         </p:nvSpPr>
         <p:spPr>
           <a:xfrm>
-            <a:off x="1051560" y="2240280"/>
-            <a:ext cx="7589520" cy="384048"/>
+            <a:off x="1051560" y="2276856"/>
+            <a:ext cx="7589520" cy="402336"/>
           </a:xfrm>
           <a:prstGeom prst="rect">
             <a:avLst/>
@@ -3798,7 +3918,9 @@
           <a:ln/>
         </p:spPr>
         <p:txBody>
-          <a:bodyPr wrap="square" lIns="0" tIns="0" rIns="0" bIns="0" rtlCol="0" anchor="ctr"/>
+          <a:bodyPr wrap="square" lIns="0" tIns="0" rIns="0" bIns="0" rtlCol="0" anchor="ctr">
+            <a:normAutofit/>
+          </a:bodyPr>
           <a:lstStyle/>
           <a:p>
             <a:pPr indent="0" marL="0">
@@ -3827,7 +3949,7 @@
         </p:nvSpPr>
         <p:spPr>
           <a:xfrm>
-            <a:off x="502920" y="2697480"/>
+            <a:off x="502920" y="2752344"/>
             <a:ext cx="384048" cy="384048"/>
           </a:xfrm>
           <a:prstGeom prst="ellipse">
@@ -3847,7 +3969,7 @@
         </p:nvSpPr>
         <p:spPr>
           <a:xfrm>
-            <a:off x="502920" y="2697480"/>
+            <a:off x="502920" y="2752344"/>
             <a:ext cx="384048" cy="384048"/>
           </a:xfrm>
           <a:prstGeom prst="rect">
@@ -3886,8 +4008,8 @@
         </p:nvSpPr>
         <p:spPr>
           <a:xfrm>
-            <a:off x="1051560" y="2697480"/>
-            <a:ext cx="7589520" cy="384048"/>
+            <a:off x="1051560" y="2752344"/>
+            <a:ext cx="7589520" cy="402336"/>
           </a:xfrm>
           <a:prstGeom prst="rect">
             <a:avLst/>
@@ -3896,7 +4018,9 @@
           <a:ln/>
         </p:spPr>
         <p:txBody>
-          <a:bodyPr wrap="square" lIns="0" tIns="0" rIns="0" bIns="0" rtlCol="0" anchor="ctr"/>
+          <a:bodyPr wrap="square" lIns="0" tIns="0" rIns="0" bIns="0" rtlCol="0" anchor="ctr">
+            <a:normAutofit/>
+          </a:bodyPr>
           <a:lstStyle/>
           <a:p>
             <a:pPr indent="0" marL="0">
@@ -3925,7 +4049,7 @@
         </p:nvSpPr>
         <p:spPr>
           <a:xfrm>
-            <a:off x="502920" y="3154680"/>
+            <a:off x="502920" y="3227832"/>
             <a:ext cx="384048" cy="384048"/>
           </a:xfrm>
           <a:prstGeom prst="ellipse">
@@ -3945,7 +4069,7 @@
         </p:nvSpPr>
         <p:spPr>
           <a:xfrm>
-            <a:off x="502920" y="3154680"/>
+            <a:off x="502920" y="3227832"/>
             <a:ext cx="384048" cy="384048"/>
           </a:xfrm>
           <a:prstGeom prst="rect">
@@ -3984,8 +4108,8 @@
         </p:nvSpPr>
         <p:spPr>
           <a:xfrm>
-            <a:off x="1051560" y="3154680"/>
-            <a:ext cx="7589520" cy="384048"/>
+            <a:off x="1051560" y="3227832"/>
+            <a:ext cx="7589520" cy="402336"/>
           </a:xfrm>
           <a:prstGeom prst="rect">
             <a:avLst/>
@@ -3994,7 +4118,9 @@
           <a:ln/>
         </p:spPr>
         <p:txBody>
-          <a:bodyPr wrap="square" lIns="0" tIns="0" rIns="0" bIns="0" rtlCol="0" anchor="ctr"/>
+          <a:bodyPr wrap="square" lIns="0" tIns="0" rIns="0" bIns="0" rtlCol="0" anchor="ctr">
+            <a:normAutofit/>
+          </a:bodyPr>
           <a:lstStyle/>
           <a:p>
             <a:pPr indent="0" marL="0">
@@ -4240,7 +4366,9 @@
           <a:ln/>
         </p:spPr>
         <p:txBody>
-          <a:bodyPr wrap="square" lIns="0" tIns="0" rIns="0" bIns="0" rtlCol="0" anchor="ctr"/>
+          <a:bodyPr wrap="square" lIns="0" tIns="0" rIns="0" bIns="0" rtlCol="0" anchor="ctr">
+            <a:normAutofit/>
+          </a:bodyPr>
           <a:lstStyle/>
           <a:p>
             <a:pPr indent="0" marL="0">
@@ -4329,7 +4457,7 @@
         <p:spPr>
           <a:xfrm>
             <a:off x="1051560" y="2313432"/>
-            <a:ext cx="7589520" cy="384048"/>
+            <a:ext cx="7589520" cy="402336"/>
           </a:xfrm>
           <a:prstGeom prst="rect">
             <a:avLst/>
@@ -4338,7 +4466,9 @@
           <a:ln/>
         </p:spPr>
         <p:txBody>
-          <a:bodyPr wrap="square" lIns="0" tIns="0" rIns="0" bIns="0" rtlCol="0" anchor="ctr"/>
+          <a:bodyPr wrap="square" lIns="0" tIns="0" rIns="0" bIns="0" rtlCol="0" anchor="ctr">
+            <a:normAutofit/>
+          </a:bodyPr>
           <a:lstStyle/>
           <a:p>
             <a:pPr indent="0" marL="0">
@@ -4353,7 +4483,7 @@
                 <a:ea typeface="Calibri" pitchFamily="34" charset="-122"/>
                 <a:cs typeface="Calibri" pitchFamily="34" charset="-120"/>
               </a:rPr>
-              <a:t>Run the provided app (docker compose up)</a:t>
+              <a:t>Run the app; draw a DFD; apply STRIDE to each element</a:t>
             </a:r>
             <a:endParaRPr lang="en-US" sz="1350" dirty="0"/>
           </a:p>
@@ -4367,7 +4497,7 @@
         </p:nvSpPr>
         <p:spPr>
           <a:xfrm>
-            <a:off x="502920" y="2770632"/>
+            <a:off x="502920" y="2788920"/>
             <a:ext cx="384048" cy="384048"/>
           </a:xfrm>
           <a:prstGeom prst="ellipse">
@@ -4387,7 +4517,7 @@
         </p:nvSpPr>
         <p:spPr>
           <a:xfrm>
-            <a:off x="502920" y="2770632"/>
+            <a:off x="502920" y="2788920"/>
             <a:ext cx="384048" cy="384048"/>
           </a:xfrm>
           <a:prstGeom prst="rect">
@@ -4426,8 +4556,8 @@
         </p:nvSpPr>
         <p:spPr>
           <a:xfrm>
-            <a:off x="1051560" y="2770632"/>
-            <a:ext cx="7589520" cy="384048"/>
+            <a:off x="1051560" y="2788920"/>
+            <a:ext cx="7589520" cy="402336"/>
           </a:xfrm>
           <a:prstGeom prst="rect">
             <a:avLst/>
@@ -4436,7 +4566,9 @@
           <a:ln/>
         </p:spPr>
         <p:txBody>
-          <a:bodyPr wrap="square" lIns="0" tIns="0" rIns="0" bIns="0" rtlCol="0" anchor="ctr"/>
+          <a:bodyPr wrap="square" lIns="0" tIns="0" rIns="0" bIns="0" rtlCol="0" anchor="ctr">
+            <a:normAutofit/>
+          </a:bodyPr>
           <a:lstStyle/>
           <a:p>
             <a:pPr indent="0" marL="0">
@@ -4451,7 +4583,7 @@
                 <a:ea typeface="Calibri" pitchFamily="34" charset="-122"/>
                 <a:cs typeface="Calibri" pitchFamily="34" charset="-120"/>
               </a:rPr>
-              <a:t>Draw a DFD: processes, stores, external entities, trust boundaries</a:t>
+              <a:t>Abuse cases: 2 personas × 2 abuse cases</a:t>
             </a:r>
             <a:endParaRPr lang="en-US" sz="1350" dirty="0"/>
           </a:p>
@@ -4465,7 +4597,7 @@
         </p:nvSpPr>
         <p:spPr>
           <a:xfrm>
-            <a:off x="502920" y="3227832"/>
+            <a:off x="502920" y="3264408"/>
             <a:ext cx="384048" cy="384048"/>
           </a:xfrm>
           <a:prstGeom prst="ellipse">
@@ -4485,7 +4617,7 @@
         </p:nvSpPr>
         <p:spPr>
           <a:xfrm>
-            <a:off x="502920" y="3227832"/>
+            <a:off x="502920" y="3264408"/>
             <a:ext cx="384048" cy="384048"/>
           </a:xfrm>
           <a:prstGeom prst="rect">
@@ -4524,8 +4656,8 @@
         </p:nvSpPr>
         <p:spPr>
           <a:xfrm>
-            <a:off x="1051560" y="3227832"/>
-            <a:ext cx="7589520" cy="384048"/>
+            <a:off x="1051560" y="3264408"/>
+            <a:ext cx="7589520" cy="402336"/>
           </a:xfrm>
           <a:prstGeom prst="rect">
             <a:avLst/>
@@ -4534,7 +4666,9 @@
           <a:ln/>
         </p:spPr>
         <p:txBody>
-          <a:bodyPr wrap="square" lIns="0" tIns="0" rIns="0" bIns="0" rtlCol="0" anchor="ctr"/>
+          <a:bodyPr wrap="square" lIns="0" tIns="0" rIns="0" bIns="0" rtlCol="0" anchor="ctr">
+            <a:normAutofit/>
+          </a:bodyPr>
           <a:lstStyle/>
           <a:p>
             <a:pPr indent="0" marL="0">
@@ -4549,7 +4683,7 @@
                 <a:ea typeface="Calibri" pitchFamily="34" charset="-122"/>
                 <a:cs typeface="Calibri" pitchFamily="34" charset="-120"/>
               </a:rPr>
-              <a:t>Apply STRIDE to each element</a:t>
+              <a:t>Deep-dive the /upload path-traversal finding</a:t>
             </a:r>
             <a:endParaRPr lang="en-US" sz="1350" dirty="0"/>
           </a:p>
@@ -4563,7 +4697,7 @@
         </p:nvSpPr>
         <p:spPr>
           <a:xfrm>
-            <a:off x="502920" y="3685032"/>
+            <a:off x="502920" y="3739896"/>
             <a:ext cx="384048" cy="384048"/>
           </a:xfrm>
           <a:prstGeom prst="ellipse">
@@ -4583,7 +4717,7 @@
         </p:nvSpPr>
         <p:spPr>
           <a:xfrm>
-            <a:off x="502920" y="3685032"/>
+            <a:off x="502920" y="3739896"/>
             <a:ext cx="384048" cy="384048"/>
           </a:xfrm>
           <a:prstGeom prst="rect">
@@ -4622,8 +4756,8 @@
         </p:nvSpPr>
         <p:spPr>
           <a:xfrm>
-            <a:off x="1051560" y="3685032"/>
-            <a:ext cx="7589520" cy="384048"/>
+            <a:off x="1051560" y="3739896"/>
+            <a:ext cx="7589520" cy="658368"/>
           </a:xfrm>
           <a:prstGeom prst="rect">
             <a:avLst/>
@@ -4632,7 +4766,9 @@
           <a:ln/>
         </p:spPr>
         <p:txBody>
-          <a:bodyPr wrap="square" lIns="0" tIns="0" rIns="0" bIns="0" rtlCol="0" anchor="ctr"/>
+          <a:bodyPr wrap="square" lIns="0" tIns="0" rIns="0" bIns="0" rtlCol="0" anchor="ctr">
+            <a:normAutofit/>
+          </a:bodyPr>
           <a:lstStyle/>
           <a:p>
             <a:pPr indent="0" marL="0">
@@ -4647,7 +4783,7 @@
                 <a:ea typeface="Calibri" pitchFamily="34" charset="-122"/>
                 <a:cs typeface="Calibri" pitchFamily="34" charset="-120"/>
               </a:rPr>
-              <a:t>Rank top 5 risks (likelihood × impact) + one mitigation each</a:t>
+              <a:t>Systems-level pass: assume one element is owned — what does it reach? Chain two low findings into one system-level claim</a:t>
             </a:r>
             <a:endParaRPr lang="en-US" sz="1350" dirty="0"/>
           </a:p>
@@ -4832,7 +4968,7 @@
                 <a:ea typeface="Arial" pitchFamily="34" charset="-122"/>
                 <a:cs typeface="Arial" pitchFamily="34" charset="-120"/>
               </a:rPr>
-              <a:t>Using AI in this course</a:t>
+              <a:t>Lab 1 — Threat-model a sample app (cont.)</a:t>
             </a:r>
             <a:endParaRPr lang="en-US" sz="2600" dirty="0"/>
           </a:p>
@@ -4846,25 +4982,16 @@
         </p:nvSpPr>
         <p:spPr>
           <a:xfrm>
-            <a:off x="457200" y="1325880"/>
-            <a:ext cx="8229600" cy="2450592"/>
-          </a:xfrm>
-          <a:prstGeom prst="roundRect">
-            <a:avLst>
-              <a:gd name="adj" fmla="val 2985"/>
-            </a:avLst>
+            <a:off x="502920" y="1325880"/>
+            <a:ext cx="384048" cy="384048"/>
+          </a:xfrm>
+          <a:prstGeom prst="ellipse">
+            <a:avLst/>
           </a:prstGeom>
           <a:solidFill>
-            <a:srgbClr val="F1F5F9"/>
+            <a:srgbClr val="E35205"/>
           </a:solidFill>
           <a:ln/>
-          <a:effectLst>
-            <a:outerShdw sx="100000" sy="100000" kx="0" ky="0" algn="bl" rotWithShape="0" blurRad="76200" dist="25400" dir="5400000">
-              <a:srgbClr val="000000">
-                <a:alpha val="12000"/>
-              </a:srgbClr>
-            </a:outerShdw>
-          </a:effectLst>
         </p:spPr>
       </p:sp>
       <p:sp>
@@ -4875,8 +5002,8 @@
         </p:nvSpPr>
         <p:spPr>
           <a:xfrm>
-            <a:off x="731520" y="1435608"/>
-            <a:ext cx="7680960" cy="2231136"/>
+            <a:off x="502920" y="1325880"/>
+            <a:ext cx="384048" cy="384048"/>
           </a:xfrm>
           <a:prstGeom prst="rect">
             <a:avLst/>
@@ -4885,18 +5012,55 @@
           <a:ln/>
         </p:spPr>
         <p:txBody>
-          <a:bodyPr wrap="square" lIns="0" tIns="0" rIns="0" bIns="0" rtlCol="0" anchor="t"/>
-          <a:lstStyle/>
-          <a:p>
-            <a:pPr marL="342900" indent="-342900">
-              <a:spcAft>
-                <a:spcPts val="600"/>
-              </a:spcAft>
-              <a:buSzPct val="100000"/>
-              <a:buChar char="•"/>
-            </a:pPr>
-            <a:r>
-              <a:rPr lang="en-US" sz="1400" dirty="0">
+          <a:bodyPr wrap="square" lIns="0" tIns="0" rIns="0" bIns="0" rtlCol="0" anchor="ctr"/>
+          <a:lstStyle/>
+          <a:p>
+            <a:pPr algn="ctr" indent="0" marL="0">
+              <a:buNone/>
+            </a:pPr>
+            <a:r>
+              <a:rPr lang="en-US" sz="1500" b="1" dirty="0">
+                <a:solidFill>
+                  <a:srgbClr val="0E1726"/>
+                </a:solidFill>
+                <a:latin typeface="Arial" pitchFamily="34" charset="0"/>
+                <a:ea typeface="Arial" pitchFamily="34" charset="-122"/>
+                <a:cs typeface="Arial" pitchFamily="34" charset="-120"/>
+              </a:rPr>
+              <a:t>5</a:t>
+            </a:r>
+            <a:endParaRPr lang="en-US" sz="1500" dirty="0"/>
+          </a:p>
+        </p:txBody>
+      </p:sp>
+      <p:sp>
+        <p:nvSpPr>
+          <p:cNvPr id="7" name="Text 4"/>
+          <p:cNvSpPr/>
+          <p:nvPr/>
+        </p:nvSpPr>
+        <p:spPr>
+          <a:xfrm>
+            <a:off x="1051560" y="1325880"/>
+            <a:ext cx="7589520" cy="402336"/>
+          </a:xfrm>
+          <a:prstGeom prst="rect">
+            <a:avLst/>
+          </a:prstGeom>
+          <a:noFill/>
+          <a:ln/>
+        </p:spPr>
+        <p:txBody>
+          <a:bodyPr wrap="square" lIns="0" tIns="0" rIns="0" bIns="0" rtlCol="0" anchor="ctr">
+            <a:normAutofit/>
+          </a:bodyPr>
+          <a:lstStyle/>
+          <a:p>
+            <a:pPr indent="0" marL="0">
+              <a:buNone/>
+            </a:pPr>
+            <a:r>
+              <a:rPr lang="en-US" sz="1350" dirty="0">
                 <a:solidFill>
                   <a:srgbClr val="1F2937"/>
                 </a:solidFill>
@@ -4904,20 +5068,99 @@
                 <a:ea typeface="Calibri" pitchFamily="34" charset="-122"/>
                 <a:cs typeface="Calibri" pitchFamily="34" charset="-120"/>
               </a:rPr>
-              <a:t>AI is allowed — and you must disclose how you used it</a:t>
-            </a:r>
-            <a:endParaRPr lang="en-US" sz="1400" dirty="0"/>
-          </a:p>
-          <a:p>
-            <a:pPr marL="342900" indent="-342900">
-              <a:spcAft>
-                <a:spcPts val="600"/>
-              </a:spcAft>
-              <a:buSzPct val="100000"/>
-              <a:buChar char="•"/>
-            </a:pPr>
-            <a:r>
-              <a:rPr lang="en-US" sz="1400" dirty="0">
+              <a:t>Turn threats into testable security requirements ("the system must … so that …")</a:t>
+            </a:r>
+            <a:endParaRPr lang="en-US" sz="1350" dirty="0"/>
+          </a:p>
+        </p:txBody>
+      </p:sp>
+      <p:sp>
+        <p:nvSpPr>
+          <p:cNvPr id="8" name="Shape 5"/>
+          <p:cNvSpPr/>
+          <p:nvPr/>
+        </p:nvSpPr>
+        <p:spPr>
+          <a:xfrm>
+            <a:off x="502920" y="1801368"/>
+            <a:ext cx="384048" cy="384048"/>
+          </a:xfrm>
+          <a:prstGeom prst="ellipse">
+            <a:avLst/>
+          </a:prstGeom>
+          <a:solidFill>
+            <a:srgbClr val="E35205"/>
+          </a:solidFill>
+          <a:ln/>
+        </p:spPr>
+      </p:sp>
+      <p:sp>
+        <p:nvSpPr>
+          <p:cNvPr id="9" name="Text 6"/>
+          <p:cNvSpPr/>
+          <p:nvPr/>
+        </p:nvSpPr>
+        <p:spPr>
+          <a:xfrm>
+            <a:off x="502920" y="1801368"/>
+            <a:ext cx="384048" cy="384048"/>
+          </a:xfrm>
+          <a:prstGeom prst="rect">
+            <a:avLst/>
+          </a:prstGeom>
+          <a:noFill/>
+          <a:ln/>
+        </p:spPr>
+        <p:txBody>
+          <a:bodyPr wrap="square" lIns="0" tIns="0" rIns="0" bIns="0" rtlCol="0" anchor="ctr"/>
+          <a:lstStyle/>
+          <a:p>
+            <a:pPr algn="ctr" indent="0" marL="0">
+              <a:buNone/>
+            </a:pPr>
+            <a:r>
+              <a:rPr lang="en-US" sz="1500" b="1" dirty="0">
+                <a:solidFill>
+                  <a:srgbClr val="0E1726"/>
+                </a:solidFill>
+                <a:latin typeface="Arial" pitchFamily="34" charset="0"/>
+                <a:ea typeface="Arial" pitchFamily="34" charset="-122"/>
+                <a:cs typeface="Arial" pitchFamily="34" charset="-120"/>
+              </a:rPr>
+              <a:t>6</a:t>
+            </a:r>
+            <a:endParaRPr lang="en-US" sz="1500" dirty="0"/>
+          </a:p>
+        </p:txBody>
+      </p:sp>
+      <p:sp>
+        <p:nvSpPr>
+          <p:cNvPr id="10" name="Text 7"/>
+          <p:cNvSpPr/>
+          <p:nvPr/>
+        </p:nvSpPr>
+        <p:spPr>
+          <a:xfrm>
+            <a:off x="1051560" y="1801368"/>
+            <a:ext cx="7589520" cy="402336"/>
+          </a:xfrm>
+          <a:prstGeom prst="rect">
+            <a:avLst/>
+          </a:prstGeom>
+          <a:noFill/>
+          <a:ln/>
+        </p:spPr>
+        <p:txBody>
+          <a:bodyPr wrap="square" lIns="0" tIns="0" rIns="0" bIns="0" rtlCol="0" anchor="ctr">
+            <a:normAutofit/>
+          </a:bodyPr>
+          <a:lstStyle/>
+          <a:p>
+            <a:pPr indent="0" marL="0">
+              <a:buNone/>
+            </a:pPr>
+            <a:r>
+              <a:rPr lang="en-US" sz="1350" dirty="0">
                 <a:solidFill>
                   <a:srgbClr val="1F2937"/>
                 </a:solidFill>
@@ -4925,20 +5168,99 @@
                 <a:ea typeface="Calibri" pitchFamily="34" charset="-122"/>
                 <a:cs typeface="Calibri" pitchFamily="34" charset="-120"/>
               </a:rPr>
-              <a:t>But AI hallucinates APIs/CVEs and writes insecure code</a:t>
-            </a:r>
-            <a:endParaRPr lang="en-US" sz="1400" dirty="0"/>
-          </a:p>
-          <a:p>
-            <a:pPr marL="342900" indent="-342900">
-              <a:spcAft>
-                <a:spcPts val="600"/>
-              </a:spcAft>
-              <a:buSzPct val="100000"/>
-              <a:buChar char="•"/>
-            </a:pPr>
-            <a:r>
-              <a:rPr lang="en-US" sz="1400" dirty="0">
+              <a:t>NoteVault (term project): DFD + top-3 threats — this kicks off your project</a:t>
+            </a:r>
+            <a:endParaRPr lang="en-US" sz="1350" dirty="0"/>
+          </a:p>
+        </p:txBody>
+      </p:sp>
+      <p:sp>
+        <p:nvSpPr>
+          <p:cNvPr id="11" name="Shape 8"/>
+          <p:cNvSpPr/>
+          <p:nvPr/>
+        </p:nvSpPr>
+        <p:spPr>
+          <a:xfrm>
+            <a:off x="502920" y="2276856"/>
+            <a:ext cx="384048" cy="384048"/>
+          </a:xfrm>
+          <a:prstGeom prst="ellipse">
+            <a:avLst/>
+          </a:prstGeom>
+          <a:solidFill>
+            <a:srgbClr val="E35205"/>
+          </a:solidFill>
+          <a:ln/>
+        </p:spPr>
+      </p:sp>
+      <p:sp>
+        <p:nvSpPr>
+          <p:cNvPr id="12" name="Text 9"/>
+          <p:cNvSpPr/>
+          <p:nvPr/>
+        </p:nvSpPr>
+        <p:spPr>
+          <a:xfrm>
+            <a:off x="502920" y="2276856"/>
+            <a:ext cx="384048" cy="384048"/>
+          </a:xfrm>
+          <a:prstGeom prst="rect">
+            <a:avLst/>
+          </a:prstGeom>
+          <a:noFill/>
+          <a:ln/>
+        </p:spPr>
+        <p:txBody>
+          <a:bodyPr wrap="square" lIns="0" tIns="0" rIns="0" bIns="0" rtlCol="0" anchor="ctr"/>
+          <a:lstStyle/>
+          <a:p>
+            <a:pPr algn="ctr" indent="0" marL="0">
+              <a:buNone/>
+            </a:pPr>
+            <a:r>
+              <a:rPr lang="en-US" sz="1500" b="1" dirty="0">
+                <a:solidFill>
+                  <a:srgbClr val="0E1726"/>
+                </a:solidFill>
+                <a:latin typeface="Arial" pitchFamily="34" charset="0"/>
+                <a:ea typeface="Arial" pitchFamily="34" charset="-122"/>
+                <a:cs typeface="Arial" pitchFamily="34" charset="-120"/>
+              </a:rPr>
+              <a:t>7</a:t>
+            </a:r>
+            <a:endParaRPr lang="en-US" sz="1500" dirty="0"/>
+          </a:p>
+        </p:txBody>
+      </p:sp>
+      <p:sp>
+        <p:nvSpPr>
+          <p:cNvPr id="13" name="Text 10"/>
+          <p:cNvSpPr/>
+          <p:nvPr/>
+        </p:nvSpPr>
+        <p:spPr>
+          <a:xfrm>
+            <a:off x="1051560" y="2276856"/>
+            <a:ext cx="7589520" cy="402336"/>
+          </a:xfrm>
+          <a:prstGeom prst="rect">
+            <a:avLst/>
+          </a:prstGeom>
+          <a:noFill/>
+          <a:ln/>
+        </p:spPr>
+        <p:txBody>
+          <a:bodyPr wrap="square" lIns="0" tIns="0" rIns="0" bIns="0" rtlCol="0" anchor="ctr">
+            <a:normAutofit/>
+          </a:bodyPr>
+          <a:lstStyle/>
+          <a:p>
+            <a:pPr indent="0" marL="0">
+              <a:buNone/>
+            </a:pPr>
+            <a:r>
+              <a:rPr lang="en-US" sz="1350" dirty="0">
                 <a:solidFill>
                   <a:srgbClr val="1F2937"/>
                 </a:solidFill>
@@ -4946,20 +5268,99 @@
                 <a:ea typeface="Calibri" pitchFamily="34" charset="-122"/>
                 <a:cs typeface="Calibri" pitchFamily="34" charset="-120"/>
               </a:rPr>
-              <a:t>You're graded on understanding, not the answer:</a:t>
-            </a:r>
-            <a:endParaRPr lang="en-US" sz="1400" dirty="0"/>
-          </a:p>
-          <a:p>
-            <a:pPr lvl="1" marL="685800" indent="-342900">
-              <a:spcAft>
-                <a:spcPts val="600"/>
-              </a:spcAft>
-              <a:buSzPct val="100000"/>
-              <a:buChar char="•"/>
-            </a:pPr>
-            <a:r>
-              <a:rPr lang="en-US" sz="1400" dirty="0">
+              <a:t>Rank top 5 risks (likelihood × impact)</a:t>
+            </a:r>
+            <a:endParaRPr lang="en-US" sz="1350" dirty="0"/>
+          </a:p>
+        </p:txBody>
+      </p:sp>
+      <p:sp>
+        <p:nvSpPr>
+          <p:cNvPr id="14" name="Shape 11"/>
+          <p:cNvSpPr/>
+          <p:nvPr/>
+        </p:nvSpPr>
+        <p:spPr>
+          <a:xfrm>
+            <a:off x="502920" y="2752344"/>
+            <a:ext cx="384048" cy="384048"/>
+          </a:xfrm>
+          <a:prstGeom prst="ellipse">
+            <a:avLst/>
+          </a:prstGeom>
+          <a:solidFill>
+            <a:srgbClr val="E35205"/>
+          </a:solidFill>
+          <a:ln/>
+        </p:spPr>
+      </p:sp>
+      <p:sp>
+        <p:nvSpPr>
+          <p:cNvPr id="15" name="Text 12"/>
+          <p:cNvSpPr/>
+          <p:nvPr/>
+        </p:nvSpPr>
+        <p:spPr>
+          <a:xfrm>
+            <a:off x="502920" y="2752344"/>
+            <a:ext cx="384048" cy="384048"/>
+          </a:xfrm>
+          <a:prstGeom prst="rect">
+            <a:avLst/>
+          </a:prstGeom>
+          <a:noFill/>
+          <a:ln/>
+        </p:spPr>
+        <p:txBody>
+          <a:bodyPr wrap="square" lIns="0" tIns="0" rIns="0" bIns="0" rtlCol="0" anchor="ctr"/>
+          <a:lstStyle/>
+          <a:p>
+            <a:pPr algn="ctr" indent="0" marL="0">
+              <a:buNone/>
+            </a:pPr>
+            <a:r>
+              <a:rPr lang="en-US" sz="1500" b="1" dirty="0">
+                <a:solidFill>
+                  <a:srgbClr val="0E1726"/>
+                </a:solidFill>
+                <a:latin typeface="Arial" pitchFamily="34" charset="0"/>
+                <a:ea typeface="Arial" pitchFamily="34" charset="-122"/>
+                <a:cs typeface="Arial" pitchFamily="34" charset="-120"/>
+              </a:rPr>
+              <a:t>8</a:t>
+            </a:r>
+            <a:endParaRPr lang="en-US" sz="1500" dirty="0"/>
+          </a:p>
+        </p:txBody>
+      </p:sp>
+      <p:sp>
+        <p:nvSpPr>
+          <p:cNvPr id="16" name="Text 13"/>
+          <p:cNvSpPr/>
+          <p:nvPr/>
+        </p:nvSpPr>
+        <p:spPr>
+          <a:xfrm>
+            <a:off x="1051560" y="2752344"/>
+            <a:ext cx="7589520" cy="658368"/>
+          </a:xfrm>
+          <a:prstGeom prst="rect">
+            <a:avLst/>
+          </a:prstGeom>
+          <a:noFill/>
+          <a:ln/>
+        </p:spPr>
+        <p:txBody>
+          <a:bodyPr wrap="square" lIns="0" tIns="0" rIns="0" bIns="0" rtlCol="0" anchor="ctr">
+            <a:normAutofit/>
+          </a:bodyPr>
+          <a:lstStyle/>
+          <a:p>
+            <a:pPr indent="0" marL="0">
+              <a:buNone/>
+            </a:pPr>
+            <a:r>
+              <a:rPr lang="en-US" sz="1350" dirty="0">
                 <a:solidFill>
                   <a:srgbClr val="1F2937"/>
                 </a:solidFill>
@@ -4967,108 +5368,45 @@
                 <a:ea typeface="Calibri" pitchFamily="34" charset="-122"/>
                 <a:cs typeface="Calibri" pitchFamily="34" charset="-120"/>
               </a:rPr>
-              <a:t>random live re-demos — explain it or score zero</a:t>
-            </a:r>
-            <a:endParaRPr lang="en-US" sz="1400" dirty="0"/>
-          </a:p>
-          <a:p>
-            <a:pPr lvl="1" marL="685800" indent="-342900">
-              <a:spcAft>
-                <a:spcPts val="600"/>
-              </a:spcAft>
-              <a:buSzPct val="100000"/>
-              <a:buChar char="•"/>
-            </a:pPr>
-            <a:r>
-              <a:rPr lang="en-US" sz="1400" dirty="0">
-                <a:solidFill>
-                  <a:srgbClr val="1F2937"/>
+              <a:t>Defend: implement one real mitigation — diff, before/after evidence, and argue whether your fix closes the bug class or just this instance</a:t>
+            </a:r>
+            <a:endParaRPr lang="en-US" sz="1350" dirty="0"/>
+          </a:p>
+        </p:txBody>
+      </p:sp>
+      <p:sp>
+        <p:nvSpPr>
+          <p:cNvPr id="17" name="Text 14"/>
+          <p:cNvSpPr/>
+          <p:nvPr/>
+        </p:nvSpPr>
+        <p:spPr>
+          <a:xfrm>
+            <a:off x="457200" y="4800600"/>
+            <a:ext cx="6949440" cy="274320"/>
+          </a:xfrm>
+          <a:prstGeom prst="rect">
+            <a:avLst/>
+          </a:prstGeom>
+          <a:noFill/>
+          <a:ln/>
+        </p:spPr>
+        <p:txBody>
+          <a:bodyPr wrap="square" lIns="0" tIns="0" rIns="0" bIns="0" rtlCol="0" anchor="ctr"/>
+          <a:lstStyle/>
+          <a:p>
+            <a:pPr indent="0" marL="0">
+              <a:buNone/>
+            </a:pPr>
+            <a:r>
+              <a:rPr lang="en-US" sz="900" dirty="0">
+                <a:solidFill>
+                  <a:srgbClr val="64748B"/>
                 </a:solidFill>
                 <a:latin typeface="Calibri" pitchFamily="34" charset="0"/>
                 <a:ea typeface="Calibri" pitchFamily="34" charset="-122"/>
                 <a:cs typeface="Calibri" pitchFamily="34" charset="-120"/>
               </a:rPr>
-              <a:t>your flags are unique to you — copying is traceable</a:t>
-            </a:r>
-            <a:endParaRPr lang="en-US" sz="1400" dirty="0"/>
-          </a:p>
-          <a:p>
-            <a:pPr lvl="1" marL="685800" indent="-342900">
-              <a:spcAft>
-                <a:spcPts val="600"/>
-              </a:spcAft>
-              <a:buSzPct val="100000"/>
-              <a:buChar char="•"/>
-            </a:pPr>
-            <a:r>
-              <a:rPr lang="en-US" sz="1400" dirty="0">
-                <a:solidFill>
-                  <a:srgbClr val="1F2937"/>
-                </a:solidFill>
-                <a:latin typeface="Calibri" pitchFamily="34" charset="0"/>
-                <a:ea typeface="Calibri" pitchFamily="34" charset="-122"/>
-                <a:cs typeface="Calibri" pitchFamily="34" charset="-120"/>
-              </a:rPr>
-              <a:t>every lab has an "Audit the AI" task: find what its answer gets wrong</a:t>
-            </a:r>
-            <a:endParaRPr lang="en-US" sz="1400" dirty="0"/>
-          </a:p>
-          <a:p>
-            <a:pPr marL="342900" indent="-342900">
-              <a:spcAft>
-                <a:spcPts val="600"/>
-              </a:spcAft>
-              <a:buSzPct val="100000"/>
-              <a:buChar char="•"/>
-            </a:pPr>
-            <a:r>
-              <a:rPr lang="en-US" sz="1400" dirty="0">
-                <a:solidFill>
-                  <a:srgbClr val="1F2937"/>
-                </a:solidFill>
-                <a:latin typeface="Calibri" pitchFamily="34" charset="0"/>
-                <a:ea typeface="Calibri" pitchFamily="34" charset="-122"/>
-                <a:cs typeface="Calibri" pitchFamily="34" charset="-120"/>
-              </a:rPr>
-              <a:t>Use AI to learn faster — never to skip the thinking</a:t>
-            </a:r>
-            <a:endParaRPr lang="en-US" sz="1400" dirty="0"/>
-          </a:p>
-        </p:txBody>
-      </p:sp>
-      <p:sp>
-        <p:nvSpPr>
-          <p:cNvPr id="7" name="Text 4"/>
-          <p:cNvSpPr/>
-          <p:nvPr/>
-        </p:nvSpPr>
-        <p:spPr>
-          <a:xfrm>
-            <a:off x="457200" y="4800600"/>
-            <a:ext cx="6949440" cy="274320"/>
-          </a:xfrm>
-          <a:prstGeom prst="rect">
-            <a:avLst/>
-          </a:prstGeom>
-          <a:noFill/>
-          <a:ln/>
-        </p:spPr>
-        <p:txBody>
-          <a:bodyPr wrap="square" lIns="0" tIns="0" rIns="0" bIns="0" rtlCol="0" anchor="ctr"/>
-          <a:lstStyle/>
-          <a:p>
-            <a:pPr indent="0" marL="0">
-              <a:buNone/>
-            </a:pPr>
-            <a:r>
-              <a:rPr lang="en-US" sz="900" dirty="0">
-                <a:solidFill>
-                  <a:srgbClr val="64748B"/>
-                </a:solidFill>
-                <a:latin typeface="Calibri" pitchFamily="34" charset="0"/>
-                <a:ea typeface="Calibri" pitchFamily="34" charset="-122"/>
-                <a:cs typeface="Calibri" pitchFamily="34" charset="-120"/>
-              </a:rPr>
               <a:t>Software Security · Week 1</a:t>
             </a:r>
             <a:endParaRPr lang="en-US" sz="900" dirty="0"/>
@@ -5077,7 +5415,7 @@
       </p:sp>
       <p:pic>
         <p:nvPicPr>
-          <p:cNvPr id="8" name="Image 1" descr="/Users/pop7/Library/CloudStorage/OneDrive-MonsterConnectCo.,Ltd/Lecture/KOSEN69 - software-security/slides/pptx/assets/logo-small.png">    </p:cNvPr>
+          <p:cNvPr id="18" name="Image 1" descr="/Users/pop7/Library/CloudStorage/OneDrive-MonsterConnectCo.,Ltd/Lecture/KOSEN69 - software-security/slides/pptx/assets/logo-small.png">    </p:cNvPr>
           <p:cNvPicPr>
             <a:picLocks noChangeAspect="1"/>
           </p:cNvPicPr>
@@ -5215,7 +5553,7 @@
                 <a:ea typeface="Arial" pitchFamily="34" charset="-122"/>
                 <a:cs typeface="Arial" pitchFamily="34" charset="-120"/>
               </a:rPr>
-              <a:t>Key takeaways</a:t>
+              <a:t>Using AI in this course</a:t>
             </a:r>
             <a:endParaRPr lang="en-US" sz="2600" dirty="0"/>
           </a:p>
@@ -5230,11 +5568,11 @@
         <p:spPr>
           <a:xfrm>
             <a:off x="457200" y="1325880"/>
-            <a:ext cx="8229600" cy="1207008"/>
+            <a:ext cx="8229600" cy="2450592"/>
           </a:xfrm>
           <a:prstGeom prst="roundRect">
             <a:avLst>
-              <a:gd name="adj" fmla="val 6061"/>
+              <a:gd name="adj" fmla="val 2985"/>
             </a:avLst>
           </a:prstGeom>
           <a:solidFill>
@@ -5259,7 +5597,7 @@
         <p:spPr>
           <a:xfrm>
             <a:off x="731520" y="1435608"/>
-            <a:ext cx="7680960" cy="987552"/>
+            <a:ext cx="7680960" cy="2231136"/>
           </a:xfrm>
           <a:prstGeom prst="rect">
             <a:avLst/>
@@ -5268,7 +5606,9 @@
           <a:ln/>
         </p:spPr>
         <p:txBody>
-          <a:bodyPr wrap="square" lIns="0" tIns="0" rIns="0" bIns="0" rtlCol="0" anchor="t"/>
+          <a:bodyPr wrap="square" lIns="0" tIns="0" rIns="0" bIns="0" rtlCol="0" anchor="t">
+            <a:normAutofit/>
+          </a:bodyPr>
           <a:lstStyle/>
           <a:p>
             <a:pPr marL="342900" indent="-342900">
@@ -5287,7 +5627,7 @@
                 <a:ea typeface="Calibri" pitchFamily="34" charset="-122"/>
                 <a:cs typeface="Calibri" pitchFamily="34" charset="-120"/>
               </a:rPr>
-              <a:t>Design for security; don't bolt it on</a:t>
+              <a:t>AI is allowed — and you must disclose how you used it</a:t>
             </a:r>
             <a:endParaRPr lang="en-US" sz="1400" dirty="0"/>
           </a:p>
@@ -5308,7 +5648,7 @@
                 <a:ea typeface="Calibri" pitchFamily="34" charset="-122"/>
                 <a:cs typeface="Calibri" pitchFamily="34" charset="-120"/>
               </a:rPr>
-              <a:t>Attackers need one gap — model the whole surface</a:t>
+              <a:t>But AI hallucinates APIs/CVEs and writes insecure code</a:t>
             </a:r>
             <a:endParaRPr lang="en-US" sz="1400" dirty="0"/>
           </a:p>
@@ -5329,7 +5669,91 @@
                 <a:ea typeface="Calibri" pitchFamily="34" charset="-122"/>
                 <a:cs typeface="Calibri" pitchFamily="34" charset="-120"/>
               </a:rPr>
-              <a:t>STRIDE + DFD = a repeatable way to find design flaws</a:t>
+              <a:t>You're graded on understanding, not the answer:</a:t>
+            </a:r>
+            <a:endParaRPr lang="en-US" sz="1400" dirty="0"/>
+          </a:p>
+          <a:p>
+            <a:pPr lvl="1" marL="685800" indent="-342900">
+              <a:spcAft>
+                <a:spcPts val="600"/>
+              </a:spcAft>
+              <a:buSzPct val="100000"/>
+              <a:buChar char="•"/>
+            </a:pPr>
+            <a:r>
+              <a:rPr lang="en-US" sz="1400" dirty="0">
+                <a:solidFill>
+                  <a:srgbClr val="1F2937"/>
+                </a:solidFill>
+                <a:latin typeface="Calibri" pitchFamily="34" charset="0"/>
+                <a:ea typeface="Calibri" pitchFamily="34" charset="-122"/>
+                <a:cs typeface="Calibri" pitchFamily="34" charset="-120"/>
+              </a:rPr>
+              <a:t>random live re-demos — explain it or score zero</a:t>
+            </a:r>
+            <a:endParaRPr lang="en-US" sz="1400" dirty="0"/>
+          </a:p>
+          <a:p>
+            <a:pPr lvl="1" marL="685800" indent="-342900">
+              <a:spcAft>
+                <a:spcPts val="600"/>
+              </a:spcAft>
+              <a:buSzPct val="100000"/>
+              <a:buChar char="•"/>
+            </a:pPr>
+            <a:r>
+              <a:rPr lang="en-US" sz="1400" dirty="0">
+                <a:solidFill>
+                  <a:srgbClr val="1F2937"/>
+                </a:solidFill>
+                <a:latin typeface="Calibri" pitchFamily="34" charset="0"/>
+                <a:ea typeface="Calibri" pitchFamily="34" charset="-122"/>
+                <a:cs typeface="Calibri" pitchFamily="34" charset="-120"/>
+              </a:rPr>
+              <a:t>your flags are unique to you — copying is traceable</a:t>
+            </a:r>
+            <a:endParaRPr lang="en-US" sz="1400" dirty="0"/>
+          </a:p>
+          <a:p>
+            <a:pPr lvl="1" marL="685800" indent="-342900">
+              <a:spcAft>
+                <a:spcPts val="600"/>
+              </a:spcAft>
+              <a:buSzPct val="100000"/>
+              <a:buChar char="•"/>
+            </a:pPr>
+            <a:r>
+              <a:rPr lang="en-US" sz="1400" dirty="0">
+                <a:solidFill>
+                  <a:srgbClr val="1F2937"/>
+                </a:solidFill>
+                <a:latin typeface="Calibri" pitchFamily="34" charset="0"/>
+                <a:ea typeface="Calibri" pitchFamily="34" charset="-122"/>
+                <a:cs typeface="Calibri" pitchFamily="34" charset="-120"/>
+              </a:rPr>
+              <a:t>every lab has an "Audit the AI" task: find what its answer gets wrong</a:t>
+            </a:r>
+            <a:endParaRPr lang="en-US" sz="1400" dirty="0"/>
+          </a:p>
+          <a:p>
+            <a:pPr marL="342900" indent="-342900">
+              <a:spcAft>
+                <a:spcPts val="600"/>
+              </a:spcAft>
+              <a:buSzPct val="100000"/>
+              <a:buChar char="•"/>
+            </a:pPr>
+            <a:r>
+              <a:rPr lang="en-US" sz="1400" dirty="0">
+                <a:solidFill>
+                  <a:srgbClr val="1F2937"/>
+                </a:solidFill>
+                <a:latin typeface="Calibri" pitchFamily="34" charset="0"/>
+                <a:ea typeface="Calibri" pitchFamily="34" charset="-122"/>
+                <a:cs typeface="Calibri" pitchFamily="34" charset="-120"/>
+              </a:rPr>
+              <a:t>Use AI to learn faster — never to skip the thinking</a:t>
             </a:r>
             <a:endParaRPr lang="en-US" sz="1400" dirty="0"/>
           </a:p>
@@ -5432,6 +5856,307 @@
       </p:grpSpPr>
       <p:sp>
         <p:nvSpPr>
+          <p:cNvPr id="2" name="Shape 0"/>
+          <p:cNvSpPr/>
+          <p:nvPr/>
+        </p:nvSpPr>
+        <p:spPr>
+          <a:xfrm>
+            <a:off x="457200" y="384048"/>
+            <a:ext cx="530352" cy="530352"/>
+          </a:xfrm>
+          <a:prstGeom prst="ellipse">
+            <a:avLst/>
+          </a:prstGeom>
+          <a:solidFill>
+            <a:srgbClr val="E35205"/>
+          </a:solidFill>
+          <a:ln/>
+          <a:effectLst>
+            <a:outerShdw sx="100000" sy="100000" kx="0" ky="0" algn="bl" rotWithShape="0" blurRad="76200" dist="25400" dir="5400000">
+              <a:srgbClr val="000000">
+                <a:alpha val="12000"/>
+              </a:srgbClr>
+            </a:outerShdw>
+          </a:effectLst>
+        </p:spPr>
+      </p:sp>
+      <p:pic>
+        <p:nvPicPr>
+          <p:cNvPr id="3" name="Image 0" descr="preencoded.png">    </p:cNvPr>
+          <p:cNvPicPr>
+            <a:picLocks noChangeAspect="1"/>
+          </p:cNvPicPr>
+          <p:nvPr/>
+        </p:nvPicPr>
+        <p:blipFill>
+          <a:blip r:embed="rId1"/>
+          <a:stretch>
+            <a:fillRect/>
+          </a:stretch>
+        </p:blipFill>
+        <p:spPr>
+          <a:xfrm>
+            <a:off x="594360" y="521208"/>
+            <a:ext cx="256032" cy="256032"/>
+          </a:xfrm>
+          <a:prstGeom prst="rect">
+            <a:avLst/>
+          </a:prstGeom>
+        </p:spPr>
+      </p:pic>
+      <p:sp>
+        <p:nvSpPr>
+          <p:cNvPr id="4" name="Text 1"/>
+          <p:cNvSpPr/>
+          <p:nvPr/>
+        </p:nvSpPr>
+        <p:spPr>
+          <a:xfrm>
+            <a:off x="1143000" y="329184"/>
+            <a:ext cx="7498080" cy="603504"/>
+          </a:xfrm>
+          <a:prstGeom prst="rect">
+            <a:avLst/>
+          </a:prstGeom>
+          <a:noFill/>
+          <a:ln/>
+        </p:spPr>
+        <p:txBody>
+          <a:bodyPr wrap="square" lIns="0" tIns="0" rIns="0" bIns="0" rtlCol="0" anchor="ctr"/>
+          <a:lstStyle/>
+          <a:p>
+            <a:pPr indent="0" marL="0">
+              <a:buNone/>
+            </a:pPr>
+            <a:r>
+              <a:rPr lang="en-US" sz="2600" b="1" dirty="0">
+                <a:solidFill>
+                  <a:srgbClr val="1F2937"/>
+                </a:solidFill>
+                <a:latin typeface="Arial" pitchFamily="34" charset="0"/>
+                <a:ea typeface="Arial" pitchFamily="34" charset="-122"/>
+                <a:cs typeface="Arial" pitchFamily="34" charset="-120"/>
+              </a:rPr>
+              <a:t>Key takeaways</a:t>
+            </a:r>
+            <a:endParaRPr lang="en-US" sz="2600" dirty="0"/>
+          </a:p>
+        </p:txBody>
+      </p:sp>
+      <p:sp>
+        <p:nvSpPr>
+          <p:cNvPr id="5" name="Shape 2"/>
+          <p:cNvSpPr/>
+          <p:nvPr/>
+        </p:nvSpPr>
+        <p:spPr>
+          <a:xfrm>
+            <a:off x="457200" y="1325880"/>
+            <a:ext cx="8229600" cy="1207008"/>
+          </a:xfrm>
+          <a:prstGeom prst="roundRect">
+            <a:avLst>
+              <a:gd name="adj" fmla="val 6061"/>
+            </a:avLst>
+          </a:prstGeom>
+          <a:solidFill>
+            <a:srgbClr val="F1F5F9"/>
+          </a:solidFill>
+          <a:ln/>
+          <a:effectLst>
+            <a:outerShdw sx="100000" sy="100000" kx="0" ky="0" algn="bl" rotWithShape="0" blurRad="76200" dist="25400" dir="5400000">
+              <a:srgbClr val="000000">
+                <a:alpha val="12000"/>
+              </a:srgbClr>
+            </a:outerShdw>
+          </a:effectLst>
+        </p:spPr>
+      </p:sp>
+      <p:sp>
+        <p:nvSpPr>
+          <p:cNvPr id="6" name="Text 3"/>
+          <p:cNvSpPr/>
+          <p:nvPr/>
+        </p:nvSpPr>
+        <p:spPr>
+          <a:xfrm>
+            <a:off x="731520" y="1435608"/>
+            <a:ext cx="7680960" cy="987552"/>
+          </a:xfrm>
+          <a:prstGeom prst="rect">
+            <a:avLst/>
+          </a:prstGeom>
+          <a:noFill/>
+          <a:ln/>
+        </p:spPr>
+        <p:txBody>
+          <a:bodyPr wrap="square" lIns="0" tIns="0" rIns="0" bIns="0" rtlCol="0" anchor="t">
+            <a:normAutofit/>
+          </a:bodyPr>
+          <a:lstStyle/>
+          <a:p>
+            <a:pPr marL="342900" indent="-342900">
+              <a:spcAft>
+                <a:spcPts val="600"/>
+              </a:spcAft>
+              <a:buSzPct val="100000"/>
+              <a:buChar char="•"/>
+            </a:pPr>
+            <a:r>
+              <a:rPr lang="en-US" sz="1400" dirty="0">
+                <a:solidFill>
+                  <a:srgbClr val="1F2937"/>
+                </a:solidFill>
+                <a:latin typeface="Calibri" pitchFamily="34" charset="0"/>
+                <a:ea typeface="Calibri" pitchFamily="34" charset="-122"/>
+                <a:cs typeface="Calibri" pitchFamily="34" charset="-120"/>
+              </a:rPr>
+              <a:t>Design for security; don't bolt it on</a:t>
+            </a:r>
+            <a:endParaRPr lang="en-US" sz="1400" dirty="0"/>
+          </a:p>
+          <a:p>
+            <a:pPr marL="342900" indent="-342900">
+              <a:spcAft>
+                <a:spcPts val="600"/>
+              </a:spcAft>
+              <a:buSzPct val="100000"/>
+              <a:buChar char="•"/>
+            </a:pPr>
+            <a:r>
+              <a:rPr lang="en-US" sz="1400" dirty="0">
+                <a:solidFill>
+                  <a:srgbClr val="1F2937"/>
+                </a:solidFill>
+                <a:latin typeface="Calibri" pitchFamily="34" charset="0"/>
+                <a:ea typeface="Calibri" pitchFamily="34" charset="-122"/>
+                <a:cs typeface="Calibri" pitchFamily="34" charset="-120"/>
+              </a:rPr>
+              <a:t>Attackers need one gap — model the whole surface</a:t>
+            </a:r>
+            <a:endParaRPr lang="en-US" sz="1400" dirty="0"/>
+          </a:p>
+          <a:p>
+            <a:pPr marL="342900" indent="-342900">
+              <a:spcAft>
+                <a:spcPts val="600"/>
+              </a:spcAft>
+              <a:buSzPct val="100000"/>
+              <a:buChar char="•"/>
+            </a:pPr>
+            <a:r>
+              <a:rPr lang="en-US" sz="1400" dirty="0">
+                <a:solidFill>
+                  <a:srgbClr val="1F2937"/>
+                </a:solidFill>
+                <a:latin typeface="Calibri" pitchFamily="34" charset="0"/>
+                <a:ea typeface="Calibri" pitchFamily="34" charset="-122"/>
+                <a:cs typeface="Calibri" pitchFamily="34" charset="-120"/>
+              </a:rPr>
+              <a:t>STRIDE + DFD = a repeatable way to find design flaws</a:t>
+            </a:r>
+            <a:endParaRPr lang="en-US" sz="1400" dirty="0"/>
+          </a:p>
+        </p:txBody>
+      </p:sp>
+      <p:sp>
+        <p:nvSpPr>
+          <p:cNvPr id="7" name="Text 4"/>
+          <p:cNvSpPr/>
+          <p:nvPr/>
+        </p:nvSpPr>
+        <p:spPr>
+          <a:xfrm>
+            <a:off x="457200" y="4800600"/>
+            <a:ext cx="6949440" cy="274320"/>
+          </a:xfrm>
+          <a:prstGeom prst="rect">
+            <a:avLst/>
+          </a:prstGeom>
+          <a:noFill/>
+          <a:ln/>
+        </p:spPr>
+        <p:txBody>
+          <a:bodyPr wrap="square" lIns="0" tIns="0" rIns="0" bIns="0" rtlCol="0" anchor="ctr"/>
+          <a:lstStyle/>
+          <a:p>
+            <a:pPr indent="0" marL="0">
+              <a:buNone/>
+            </a:pPr>
+            <a:r>
+              <a:rPr lang="en-US" sz="900" dirty="0">
+                <a:solidFill>
+                  <a:srgbClr val="64748B"/>
+                </a:solidFill>
+                <a:latin typeface="Calibri" pitchFamily="34" charset="0"/>
+                <a:ea typeface="Calibri" pitchFamily="34" charset="-122"/>
+                <a:cs typeface="Calibri" pitchFamily="34" charset="-120"/>
+              </a:rPr>
+              <a:t>Software Security · Week 1</a:t>
+            </a:r>
+            <a:endParaRPr lang="en-US" sz="900" dirty="0"/>
+          </a:p>
+        </p:txBody>
+      </p:sp>
+      <p:pic>
+        <p:nvPicPr>
+          <p:cNvPr id="8" name="Image 1" descr="/Users/pop7/Library/CloudStorage/OneDrive-MonsterConnectCo.,Ltd/Lecture/KOSEN69 - software-security/slides/pptx/assets/logo-small.png">    </p:cNvPr>
+          <p:cNvPicPr>
+            <a:picLocks noChangeAspect="1"/>
+          </p:cNvPicPr>
+          <p:nvPr/>
+        </p:nvPicPr>
+        <p:blipFill>
+          <a:blip r:embed="rId2"/>
+          <a:stretch>
+            <a:fillRect/>
+          </a:stretch>
+        </p:blipFill>
+        <p:spPr>
+          <a:xfrm>
+            <a:off x="7882128" y="4700016"/>
+            <a:ext cx="768096" cy="356616"/>
+          </a:xfrm>
+          <a:prstGeom prst="rect">
+            <a:avLst/>
+          </a:prstGeom>
+        </p:spPr>
+      </p:pic>
+    </p:spTree>
+  </p:cSld>
+  <p:clrMapOvr>
+    <a:masterClrMapping/>
+  </p:clrMapOvr>
+</p:sld>
+</file>
+
+<file path=ppt/slides/slide18.xml><?xml version="1.0" encoding="utf-8"?>
+<p:sld xmlns:a="http://schemas.openxmlformats.org/drawingml/2006/main" xmlns:r="http://schemas.openxmlformats.org/officeDocument/2006/relationships" xmlns:p="http://schemas.openxmlformats.org/presentationml/2006/main">
+  <p:cSld name="Slide 18">
+    <p:bg>
+      <p:bgPr>
+        <a:solidFill>
+          <a:srgbClr val="FFFFFF"/>
+        </a:solidFill>
+      </p:bgPr>
+    </p:bg>
+    <p:spTree>
+      <p:nvGrpSpPr>
+        <p:cNvPr id="1" name=""/>
+        <p:cNvGrpSpPr/>
+        <p:nvPr/>
+      </p:nvGrpSpPr>
+      <p:grpSpPr>
+        <a:xfrm>
+          <a:off x="0" y="0"/>
+          <a:ext cx="0" cy="0"/>
+          <a:chOff x="0" y="0"/>
+          <a:chExt cx="0" cy="0"/>
+        </a:xfrm>
+      </p:grpSpPr>
+      <p:sp>
+        <p:nvSpPr>
           <p:cNvPr id="2" name="Text 0"/>
           <p:cNvSpPr/>
           <p:nvPr/>
@@ -5701,7 +6426,9 @@
           <a:ln/>
         </p:spPr>
         <p:txBody>
-          <a:bodyPr wrap="square" lIns="0" tIns="0" rIns="0" bIns="0" rtlCol="0" anchor="t"/>
+          <a:bodyPr wrap="square" lIns="0" tIns="0" rIns="0" bIns="0" rtlCol="0" anchor="t">
+            <a:normAutofit/>
+          </a:bodyPr>
           <a:lstStyle/>
           <a:p>
             <a:pPr marL="342900" indent="-342900">
@@ -6063,7 +6790,9 @@
           <a:ln/>
         </p:spPr>
         <p:txBody>
-          <a:bodyPr wrap="square" lIns="0" tIns="0" rIns="0" bIns="0" rtlCol="0" anchor="t"/>
+          <a:bodyPr wrap="square" lIns="0" tIns="0" rIns="0" bIns="0" rtlCol="0" anchor="t">
+            <a:normAutofit/>
+          </a:bodyPr>
           <a:lstStyle/>
           <a:p>
             <a:pPr marL="342900" indent="-342900">
@@ -6383,7 +7112,9 @@
           <a:ln/>
         </p:spPr>
         <p:txBody>
-          <a:bodyPr wrap="square" lIns="0" tIns="0" rIns="0" bIns="0" rtlCol="0" anchor="t"/>
+          <a:bodyPr wrap="square" lIns="0" tIns="0" rIns="0" bIns="0" rtlCol="0" anchor="t">
+            <a:normAutofit/>
+          </a:bodyPr>
           <a:lstStyle/>
           <a:p>
             <a:pPr marL="342900" indent="-342900">
@@ -6490,7 +7221,9 @@
           <a:ln/>
         </p:spPr>
         <p:txBody>
-          <a:bodyPr wrap="square" lIns="0" tIns="0" rIns="0" bIns="0" rtlCol="0" anchor="ctr"/>
+          <a:bodyPr wrap="square" lIns="0" tIns="0" rIns="0" bIns="0" rtlCol="0" anchor="ctr">
+            <a:normAutofit/>
+          </a:bodyPr>
           <a:lstStyle/>
           <a:p>
             <a:pPr indent="0" marL="0">
@@ -6743,7 +7476,9 @@
           <a:ln/>
         </p:spPr>
         <p:txBody>
-          <a:bodyPr wrap="square" lIns="0" tIns="0" rIns="0" bIns="0" rtlCol="0" anchor="t"/>
+          <a:bodyPr wrap="square" lIns="0" tIns="0" rIns="0" bIns="0" rtlCol="0" anchor="t">
+            <a:normAutofit/>
+          </a:bodyPr>
           <a:lstStyle/>
           <a:p>
             <a:pPr marL="342900" indent="-342900">
@@ -6804,7 +7539,7 @@
                 <a:ea typeface="Calibri" pitchFamily="34" charset="-122"/>
                 <a:cs typeface="Calibri" pitchFamily="34" charset="-120"/>
               </a:rPr>
-              <a:t>Think in misuse cases, not just use cases</a:t>
+              <a:t>Think in abuse cases, not just use cases</a:t>
             </a:r>
             <a:endParaRPr lang="en-US" sz="1400" dirty="0"/>
           </a:p>
@@ -7063,7 +7798,9 @@
           <a:ln/>
         </p:spPr>
         <p:txBody>
-          <a:bodyPr wrap="square" lIns="0" tIns="0" rIns="0" bIns="0" rtlCol="0" anchor="t"/>
+          <a:bodyPr wrap="square" lIns="0" tIns="0" rIns="0" bIns="0" rtlCol="0" anchor="t">
+            <a:normAutofit/>
+          </a:bodyPr>
           <a:lstStyle/>
           <a:p>
             <a:pPr marL="342900" indent="-342900">
@@ -7324,11 +8061,11 @@
         <p:spPr>
           <a:xfrm>
             <a:off x="457200" y="1325880"/>
-            <a:ext cx="8229600" cy="1042416"/>
+            <a:ext cx="8229600" cy="932688"/>
           </a:xfrm>
           <a:prstGeom prst="roundRect">
             <a:avLst>
-              <a:gd name="adj" fmla="val 5263"/>
+              <a:gd name="adj" fmla="val 5882"/>
             </a:avLst>
           </a:prstGeom>
           <a:solidFill>
@@ -7351,7 +8088,7 @@
         <p:spPr>
           <a:xfrm>
             <a:off x="640080" y="1399032"/>
-            <a:ext cx="7863840" cy="896112"/>
+            <a:ext cx="7863840" cy="786384"/>
           </a:xfrm>
           <a:prstGeom prst="rect">
             <a:avLst/>
@@ -7360,7 +8097,9 @@
           <a:ln/>
         </p:spPr>
         <p:txBody>
-          <a:bodyPr wrap="square" lIns="0" tIns="0" rIns="0" bIns="0" rtlCol="0" anchor="t"/>
+          <a:bodyPr wrap="square" lIns="0" tIns="0" rIns="0" bIns="0" rtlCol="0" anchor="t">
+            <a:normAutofit/>
+          </a:bodyPr>
           <a:lstStyle/>
           <a:p>
             <a:pPr indent="0" marL="0">
@@ -7423,12 +8162,12 @@
         </p:nvSpPr>
         <p:spPr>
           <a:xfrm>
-            <a:off x="457200" y="2532888"/>
-            <a:ext cx="8229600" cy="1207008"/>
+            <a:off x="457200" y="2423160"/>
+            <a:ext cx="8229600" cy="2121408"/>
           </a:xfrm>
           <a:prstGeom prst="roundRect">
             <a:avLst>
-              <a:gd name="adj" fmla="val 6061"/>
+              <a:gd name="adj" fmla="val 3448"/>
             </a:avLst>
           </a:prstGeom>
           <a:solidFill>
@@ -7452,8 +8191,8 @@
         </p:nvSpPr>
         <p:spPr>
           <a:xfrm>
-            <a:off x="731520" y="2642616"/>
-            <a:ext cx="7680960" cy="987552"/>
+            <a:off x="731520" y="2532888"/>
+            <a:ext cx="7680960" cy="1901952"/>
           </a:xfrm>
           <a:prstGeom prst="rect">
             <a:avLst/>
@@ -7462,7 +8201,9 @@
           <a:ln/>
         </p:spPr>
         <p:txBody>
-          <a:bodyPr wrap="square" lIns="0" tIns="0" rIns="0" bIns="0" rtlCol="0" anchor="t"/>
+          <a:bodyPr wrap="square" lIns="0" tIns="0" rIns="0" bIns="0" rtlCol="0" anchor="t">
+            <a:normAutofit/>
+          </a:bodyPr>
           <a:lstStyle/>
           <a:p>
             <a:pPr marL="342900" indent="-342900">
@@ -7523,7 +8264,28 @@
                 <a:ea typeface="Calibri" pitchFamily="34" charset="-122"/>
                 <a:cs typeface="Calibri" pitchFamily="34" charset="-120"/>
               </a:rPr>
-              <a:t>../../etc/passwd as a filename → path traversal (read outside uploads/)</a:t>
+              <a:t>../../escaped.txt as a filename → the app saves it there — arbitrary-file-write, unauthenticated, anywhere the process can reach (not "overwrite a same-name file" — write to a path you chose)</a:t>
+            </a:r>
+            <a:endParaRPr lang="en-US" sz="1400" dirty="0"/>
+          </a:p>
+          <a:p>
+            <a:pPr marL="342900" indent="-342900">
+              <a:spcAft>
+                <a:spcPts val="600"/>
+              </a:spcAft>
+              <a:buSzPct val="100000"/>
+              <a:buChar char="•"/>
+            </a:pPr>
+            <a:r>
+              <a:rPr lang="en-US" sz="1400" dirty="0">
+                <a:solidFill>
+                  <a:srgbClr val="1F2937"/>
+                </a:solidFill>
+                <a:latin typeface="Calibri" pitchFamily="34" charset="0"/>
+                <a:ea typeface="Calibri" pitchFamily="34" charset="-122"/>
+                <a:cs typeface="Calibri" pitchFamily="34" charset="-120"/>
+              </a:rPr>
+              <a:t>/files/&lt;name&gt; (the read path) is comparatively well-defended — Werkzeug's safe_join blocks the same trick</a:t>
             </a:r>
             <a:endParaRPr lang="en-US" sz="1400" dirty="0"/>
           </a:p>
@@ -9234,11 +9996,11 @@
         <p:spPr>
           <a:xfrm>
             <a:off x="457200" y="1325880"/>
-            <a:ext cx="8229600" cy="2139696"/>
+            <a:ext cx="8229600" cy="2743200"/>
           </a:xfrm>
           <a:prstGeom prst="roundRect">
             <a:avLst>
-              <a:gd name="adj" fmla="val 3419"/>
+              <a:gd name="adj" fmla="val 2667"/>
             </a:avLst>
           </a:prstGeom>
           <a:solidFill>
@@ -9263,7 +10025,7 @@
         <p:spPr>
           <a:xfrm>
             <a:off x="731520" y="1435608"/>
-            <a:ext cx="7680960" cy="1920240"/>
+            <a:ext cx="7680960" cy="2523744"/>
           </a:xfrm>
           <a:prstGeom prst="rect">
             <a:avLst/>
@@ -9272,7 +10034,9 @@
           <a:ln/>
         </p:spPr>
         <p:txBody>
-          <a:bodyPr wrap="square" lIns="0" tIns="0" rIns="0" bIns="0" rtlCol="0" anchor="t"/>
+          <a:bodyPr wrap="square" lIns="0" tIns="0" rIns="0" bIns="0" rtlCol="0" anchor="t">
+            <a:normAutofit/>
+          </a:bodyPr>
           <a:lstStyle/>
           <a:p>
             <a:pPr marL="342900" indent="-342900">
@@ -9312,7 +10076,7 @@
                 <a:ea typeface="Calibri" pitchFamily="34" charset="-122"/>
                 <a:cs typeface="Calibri" pitchFamily="34" charset="-120"/>
               </a:rPr>
-              <a:t>T — overwrite another user's file (same name)</a:t>
+              <a:t>T — ../ filename writes outside uploads/ — arbitrary-file-write, not just an overwrite</a:t>
             </a:r>
             <a:endParaRPr lang="en-US" sz="1400" dirty="0"/>
           </a:p>
@@ -9354,7 +10118,7 @@
                 <a:ea typeface="Calibri" pitchFamily="34" charset="-122"/>
                 <a:cs typeface="Calibri" pitchFamily="34" charset="-120"/>
               </a:rPr>
-              <a:t>I — ../ filename reads files outside the folder</a:t>
+              <a:t>I — the read path (/files/&lt;name&gt;) is comparatively well-defended (Werkzeug blocks traversal there) — this element's real risk is on the write side, not this letter</a:t>
             </a:r>
             <a:endParaRPr lang="en-US" sz="1400" dirty="0"/>
           </a:p>

</xml_diff>

<commit_message>
docs(week01): surface the new digital EoP deck across related pages
The lab README, readings list, lecture slide, and instructor lesson
plan all still described the Elevation of Privilege game as a
print-and-cut-only dependency. Point them at the built-in /sim/eop-deck
digital deck (added to the worksheet in the prior commit) so a missing
printer/scissors is no longer treated as a session risk.

Co-Authored-By: Claude Sonnet 5 <noreply@anthropic.com>
</commit_message>
<xml_diff>
--- a/slides/pptx/week01.pptx
+++ b/slides/pptx/week01.pptx
@@ -1139,7 +1139,7 @@
           <a:p>
             <a:r>
               <a:rPr lang="en-US" dirty="0"/>
-              <a:t>Explain the game before the lab: it gamifies the STRIDE pass we just did. Each suit = a STRIDE category; you play a card by naming a concrete threat on the DFD. Make it competitive (leaderboard). It lowers the barrier for students who freeze on a blank page. ~3 min.</a:t>
+              <a:t>Explain the game before the lab: it gamifies the STRIDE pass we just did. Each suit = a STRIDE category; you play a card by naming a concrete threat on the DFD. Make it competitive (leaderboard). It lowers the barrier for students who freeze on a blank page. Mention the digital deck up front so no one wastes time hunting for a printer. ~3 min.</a:t>
             </a:r>
             <a:endParaRPr lang="en-US" dirty="0"/>
           </a:p>
@@ -4643,11 +4643,11 @@
         <p:spPr>
           <a:xfrm>
             <a:off x="457200" y="1325880"/>
-            <a:ext cx="8229600" cy="1517904"/>
+            <a:ext cx="8229600" cy="2029968"/>
           </a:xfrm>
           <a:prstGeom prst="roundRect">
             <a:avLst>
-              <a:gd name="adj" fmla="val 4819"/>
+              <a:gd name="adj" fmla="val 3604"/>
             </a:avLst>
           </a:prstGeom>
           <a:solidFill>
@@ -4672,7 +4672,7 @@
         <p:spPr>
           <a:xfrm>
             <a:off x="731520" y="1435608"/>
-            <a:ext cx="7680960" cy="1298448"/>
+            <a:ext cx="7680960" cy="1810512"/>
           </a:xfrm>
           <a:prstGeom prst="rect">
             <a:avLst/>
@@ -4702,7 +4702,7 @@
                 <a:ea typeface="Calibri" pitchFamily="34" charset="-122"/>
                 <a:cs typeface="Calibri" pitchFamily="34" charset="-120"/>
               </a:rPr>
-              <a:t>Microsoft's free STRIDE card deck</a:t>
+              <a:t>Microsoft's free STRIDE card deck — github.com/adamshostack/eop</a:t>
             </a:r>
             <a:endParaRPr lang="en-US" sz="1400" dirty="0"/>
           </a:p>
@@ -4766,6 +4766,27 @@
                 <a:cs typeface="Calibri" pitchFamily="34" charset="-120"/>
               </a:rPr>
               <a:t>Outcome: a team-built STRIDE model</a:t>
+            </a:r>
+            <a:endParaRPr lang="en-US" sz="1400" dirty="0"/>
+          </a:p>
+          <a:p>
+            <a:pPr marL="342900" indent="-342900">
+              <a:spcAft>
+                <a:spcPts val="600"/>
+              </a:spcAft>
+              <a:buSzPct val="100000"/>
+              <a:buChar char="•"/>
+            </a:pPr>
+            <a:r>
+              <a:rPr lang="en-US" sz="1400" dirty="0">
+                <a:solidFill>
+                  <a:srgbClr val="1F2937"/>
+                </a:solidFill>
+                <a:latin typeface="Calibri" pitchFamily="34" charset="0"/>
+                <a:ea typeface="Calibri" pitchFamily="34" charset="-122"/>
+                <a:cs typeface="Calibri" pitchFamily="34" charset="-120"/>
+              </a:rPr>
+              <a:t>No printer? Worksheet Task 3 has a built-in digital deck — same 78 cards, one shared screen</a:t>
             </a:r>
             <a:endParaRPr lang="en-US" sz="1400" dirty="0"/>
           </a:p>

</xml_diff>